<commit_message>
fix(diagramming): route dense deployment diagrams to drawio
</commit_message>
<xml_diff>
--- a/plugins/diagramming/docs/decks/diagramming-hero-diagrams.pptx
+++ b/plugins/diagramming/docs/decks/diagramming-hero-diagrams.pptx
@@ -594,7 +594,7 @@
           <a:p>
             <a:r>
               <a:rPr lang="en-US" dirty="0"/>
-              <a:t>Hand-authored canonical reference for what Katalyst is for. 'Fast in the wrong direction is worse than slow.' The cadence-direction matrix names the danger zone (fast-wrong, agentic alone), the target state (fast-right, Katalyst), the pre-AI slow-but-filtered state, and the post-AI cheap-and-unfiltered state. The pre-AI cost-of-features acted as a buffer that filtered out wrong-direction work; AI removed the cost, the filter is gone, Katalyst's taxonomy replaces it. Authority lives outside the developer harness — Product Owner, HCD/UX, Architect, Mission Owner are sources of authoritative judgment. Three taxonomy pillars: Need, Design Intent, Implementation Reality — with acknowledged GAP that visual design intent has no Forge artifact yet.</a:t>
+              <a:t>Hand-authored canonical reference for what Katalyst is for. 'Fast in the wrong direction is worse than slow.' The cadence-direction matrix names the danger zone (fast-wrong, agentic alone), the target state (fast-right, Katalyst), the pre-AI slow-but-filtered state, and the post-AI cheap-and-unfiltered state. The pre-AI cost-of-features acted as a buffer that filtered out wrong-direction work; AI removed the cost, the filter is gone, Katalyst's taxonomy replaces it. Authority lives outside the developer harness: Product Owner, HCD/UX, Architect, Mission Owner are sources of authoritative judgment. Three taxonomy pillars: Need, Design Intent, Implementation Reality, with acknowledged GAP that visual design intent has no Forge artifact yet.</a:t>
             </a:r>
             <a:endParaRPr lang="en-US" dirty="0"/>
           </a:p>
@@ -683,10 +683,10 @@
             <a:r>
               <a:rPr lang="en-US" dirty="0"/>
               <a:t>Three loops, three cadences, three authority sets.
-Outer loop (cadence: quarters → years; authority: leadership + mission stakeholder): vision → need → design system → design intent. Direction gets set here.
-Inner loop (cadence: days → weeks; authority: PM + HCD + UX + Eng + architect): frame → IA → wireframes → mockups → validation → build/ship → design QA. The per-feature design iteration. HCD/UX is irreplaceable — AI cannot synthesize visual design intent.
-Hypothesis loop (cadence: always-on; authority: PM + Research + Data): hypothesis statement → success metrics + kill criteria → telemetry → outcome (CONFIRMED / REFUTED / PARTIAL). Real user data is the only thing that can answer the hypothesis.
-Pattern extraction (orange thick arrow) flows CONFIRMED outcomes back into the Outer Design System — the load-bearing connection.</a:t>
+Outer loop (cadence: quarters to years; authority: leadership + mission stakeholder): vision to need to design system to design intent. Direction gets set here.
+Inner loop (cadence: days to weeks; authority: PM + HCD + UX + Eng + architect): frame to IA to wireframes to mockups to validation to build/ship to design QA. The per-feature design iteration. HCD/UX is irreplaceable because AI cannot synthesize visual design intent.
+Hypothesis loop (cadence: always-on; authority: PM + Research + Data): hypothesis statement to success metrics + kill criteria to telemetry to outcome (CONFIRMED / REFUTED / PARTIAL). Real user data is the only thing that can answer the hypothesis.
+Pattern extraction flows CONFIRMED outcomes back into the Outer Design System.</a:t>
             </a:r>
             <a:endParaRPr lang="en-US" dirty="0"/>
           </a:p>
@@ -866,8 +866,8 @@
           <a:p>
             <a:r>
               <a:rPr lang="en-US" dirty="0"/>
-              <a:t>The plugin's take on the same thesis Aaron hand-authored in slide 1. Software only matters if it can prove its value. SaaS proves value via usage because users have AGENCY. Enterprise / government has no agency — usage proves nothing. Value must be DESCRIBED. Historically descriptions happen at human speed; agents work at agent speed; gap widens; value-proof fails. Katalyst surfaces value at agent speed via the three-pillar taxonomy.
-Simpler than the v2 — same core argument without the cadence-direction matrix or the cost-buffer framing. Captured here as proof the plugin can render real conceptual content from a structured spec, not just code-derived diagrams.</a:t>
+              <a:t>The plugin's take on the same thesis Aaron hand-authored in slide 1. Software only matters if it can prove its value. SaaS proves value via usage because users have AGENCY. Enterprise / government has no agency; usage proves nothing. Value must be DESCRIBED. Historically descriptions happen at human speed; agents work at agent speed; gap widens; value-proof fails. Katalyst surfaces value at agent speed via the three-pillar taxonomy.
+Simpler than the v2, with the same core argument without the cadence-direction matrix or the cost-buffer framing. Captured here as proof the plugin can render real conceptual content from a structured spec, not just code-derived diagrams.</a:t>
             </a:r>
             <a:endParaRPr lang="en-US" dirty="0"/>
           </a:p>
@@ -1273,7 +1273,7 @@
                 <a:ea typeface="Helvetica Neue" pitchFamily="34" charset="-122"/>
                 <a:cs typeface="Helvetica Neue" pitchFamily="34" charset="-120"/>
               </a:rPr>
-              <a:t>Diagramming plugin — RIC-353 hero diagrams</a:t>
+              <a:t>Diagramming plugin - RIC-353 hero diagrams</a:t>
             </a:r>
             <a:endParaRPr lang="en-US" sz="4400" dirty="0"/>
           </a:p>
@@ -1312,7 +1312,7 @@
                 <a:ea typeface="Helvetica Neue" pitchFamily="34" charset="-122"/>
                 <a:cs typeface="Helvetica Neue" pitchFamily="34" charset="-120"/>
               </a:rPr>
-              <a:t>Fareez Ahmed · esimplicity platform team</a:t>
+              <a:t>Fareez Ahmed, esimplicity platform team</a:t>
             </a:r>
             <a:endParaRPr lang="en-US" sz="1800" dirty="0"/>
           </a:p>
@@ -1401,7 +1401,7 @@
                 <a:ea typeface="Helvetica Neue" pitchFamily="34" charset="-122"/>
                 <a:cs typeface="Helvetica Neue" pitchFamily="34" charset="-120"/>
               </a:rPr>
-              <a:t>Why Katalyst exists — Aaron's expanded thesis (v2)</a:t>
+              <a:t>Why Katalyst exists - Aaron's expanded thesis (v2)</a:t>
             </a:r>
             <a:endParaRPr lang="en-US" sz="2400" dirty="0"/>
           </a:p>
@@ -1440,7 +1440,7 @@
                 <a:ea typeface="Helvetica Neue" pitchFamily="34" charset="-122"/>
                 <a:cs typeface="Helvetica Neue" pitchFamily="34" charset="-120"/>
               </a:rPr>
-              <a:t>Cadence-direction matrix · cost-buffer collapse · authority outside the harness · three taxonomy pillars</a:t>
+              <a:t>Cadence-direction matrix, cost-buffer collapse, authority outside the harness, three taxonomy pillars</a:t>
             </a:r>
             <a:endParaRPr lang="en-US" sz="1200" dirty="0"/>
           </a:p>
@@ -1503,7 +1503,7 @@
                 <a:ea typeface="Helvetica Neue" pitchFamily="34" charset="-122"/>
                 <a:cs typeface="Helvetica Neue" pitchFamily="34" charset="-120"/>
               </a:rPr>
-              <a:t>Diagramming plugin — RIC-353 hero diagrams   ·   Fareez Ahmed · esimplicity platform team</a:t>
+              <a:t>Diagramming plugin - RIC-353 hero diagrams   ·   Fareez Ahmed, esimplicity platform team</a:t>
             </a:r>
             <a:endParaRPr lang="en-US" sz="900" dirty="0"/>
           </a:p>
@@ -1631,7 +1631,7 @@
                 <a:ea typeface="Helvetica Neue" pitchFamily="34" charset="-122"/>
                 <a:cs typeface="Helvetica Neue" pitchFamily="34" charset="-120"/>
               </a:rPr>
-              <a:t>RIC-401 — The 3-loop design process</a:t>
+              <a:t>RIC-401 - The 3-loop design process</a:t>
             </a:r>
             <a:endParaRPr lang="en-US" sz="2400" dirty="0"/>
           </a:p>
@@ -1670,7 +1670,7 @@
                 <a:ea typeface="Helvetica Neue" pitchFamily="34" charset="-122"/>
                 <a:cs typeface="Helvetica Neue" pitchFamily="34" charset="-120"/>
               </a:rPr>
-              <a:t>outer (quarters→years) · inner (days→weeks) · hypothesis (always-on)</a:t>
+              <a:t>outer (quarters to years), inner (days to weeks), hypothesis (always-on)</a:t>
             </a:r>
             <a:endParaRPr lang="en-US" sz="1200" dirty="0"/>
           </a:p>
@@ -1733,7 +1733,7 @@
                 <a:ea typeface="Helvetica Neue" pitchFamily="34" charset="-122"/>
                 <a:cs typeface="Helvetica Neue" pitchFamily="34" charset="-120"/>
               </a:rPr>
-              <a:t>Diagramming plugin — RIC-353 hero diagrams   ·   Fareez Ahmed · esimplicity platform team</a:t>
+              <a:t>Diagramming plugin - RIC-353 hero diagrams   ·   Fareez Ahmed, esimplicity platform team</a:t>
             </a:r>
             <a:endParaRPr lang="en-US" sz="900" dirty="0"/>
           </a:p>
@@ -1861,7 +1861,7 @@
                 <a:ea typeface="Helvetica Neue" pitchFamily="34" charset="-122"/>
                 <a:cs typeface="Helvetica Neue" pitchFamily="34" charset="-120"/>
               </a:rPr>
-              <a:t>Katalyst taxonomy — artifact dependencies</a:t>
+              <a:t>Katalyst taxonomy - artifact dependencies</a:t>
             </a:r>
             <a:endParaRPr lang="en-US" sz="2400" dirty="0"/>
           </a:p>
@@ -1900,7 +1900,7 @@
                 <a:ea typeface="Helvetica Neue" pitchFamily="34" charset="-122"/>
                 <a:cs typeface="Helvetica Neue" pitchFamily="34" charset="-120"/>
               </a:rPr>
-              <a:t>Three pillars · cross-pillar refs labeled with frontmatter field names</a:t>
+              <a:t>Three pillars, cross-pillar refs labeled with frontmatter field names</a:t>
             </a:r>
             <a:endParaRPr lang="en-US" sz="1200" dirty="0"/>
           </a:p>
@@ -1963,7 +1963,7 @@
                 <a:ea typeface="Helvetica Neue" pitchFamily="34" charset="-122"/>
                 <a:cs typeface="Helvetica Neue" pitchFamily="34" charset="-120"/>
               </a:rPr>
-              <a:t>Diagramming plugin — RIC-353 hero diagrams   ·   Fareez Ahmed · esimplicity platform team</a:t>
+              <a:t>Diagramming plugin - RIC-353 hero diagrams   ·   Fareez Ahmed, esimplicity platform team</a:t>
             </a:r>
             <a:endParaRPr lang="en-US" sz="900" dirty="0"/>
           </a:p>
@@ -2091,7 +2091,7 @@
                 <a:ea typeface="Helvetica Neue" pitchFamily="34" charset="-122"/>
                 <a:cs typeface="Helvetica Neue" pitchFamily="34" charset="-120"/>
               </a:rPr>
-              <a:t>Why Katalyst exists — plugin-rendered v1</a:t>
+              <a:t>Why Katalyst exists - plugin-rendered v1</a:t>
             </a:r>
             <a:endParaRPr lang="en-US" sz="2400" dirty="0"/>
           </a:p>
@@ -2193,7 +2193,7 @@
                 <a:ea typeface="Helvetica Neue" pitchFamily="34" charset="-122"/>
                 <a:cs typeface="Helvetica Neue" pitchFamily="34" charset="-120"/>
               </a:rPr>
-              <a:t>Diagramming plugin — RIC-353 hero diagrams   ·   Fareez Ahmed · esimplicity platform team</a:t>
+              <a:t>Diagramming plugin - RIC-353 hero diagrams   ·   Fareez Ahmed, esimplicity platform team</a:t>
             </a:r>
             <a:endParaRPr lang="en-US" sz="900" dirty="0"/>
           </a:p>

</xml_diff>